<commit_message>
Changed the software architecture bitmap
</commit_message>
<xml_diff>
--- a/Doc/Software architektur.pptx
+++ b/Doc/Software architektur.pptx
@@ -259,7 +259,7 @@
           <a:p>
             <a:fld id="{0437B173-2941-45F4-97BE-951FF945D21E}" type="datetimeFigureOut">
               <a:rPr lang="de-DE" smtClean="0"/>
-              <a:t>04.08.2026</a:t>
+              <a:t>16.08.2026</a:t>
             </a:fld>
             <a:endParaRPr lang="de-DE"/>
           </a:p>
@@ -457,7 +457,7 @@
           <a:p>
             <a:fld id="{0437B173-2941-45F4-97BE-951FF945D21E}" type="datetimeFigureOut">
               <a:rPr lang="de-DE" smtClean="0"/>
-              <a:t>04.08.2026</a:t>
+              <a:t>16.08.2026</a:t>
             </a:fld>
             <a:endParaRPr lang="de-DE"/>
           </a:p>
@@ -665,7 +665,7 @@
           <a:p>
             <a:fld id="{0437B173-2941-45F4-97BE-951FF945D21E}" type="datetimeFigureOut">
               <a:rPr lang="de-DE" smtClean="0"/>
-              <a:t>04.08.2026</a:t>
+              <a:t>16.08.2026</a:t>
             </a:fld>
             <a:endParaRPr lang="de-DE"/>
           </a:p>
@@ -863,7 +863,7 @@
           <a:p>
             <a:fld id="{0437B173-2941-45F4-97BE-951FF945D21E}" type="datetimeFigureOut">
               <a:rPr lang="de-DE" smtClean="0"/>
-              <a:t>04.08.2026</a:t>
+              <a:t>16.08.2026</a:t>
             </a:fld>
             <a:endParaRPr lang="de-DE"/>
           </a:p>
@@ -1138,7 +1138,7 @@
           <a:p>
             <a:fld id="{0437B173-2941-45F4-97BE-951FF945D21E}" type="datetimeFigureOut">
               <a:rPr lang="de-DE" smtClean="0"/>
-              <a:t>04.08.2026</a:t>
+              <a:t>16.08.2026</a:t>
             </a:fld>
             <a:endParaRPr lang="de-DE"/>
           </a:p>
@@ -1403,7 +1403,7 @@
           <a:p>
             <a:fld id="{0437B173-2941-45F4-97BE-951FF945D21E}" type="datetimeFigureOut">
               <a:rPr lang="de-DE" smtClean="0"/>
-              <a:t>04.08.2026</a:t>
+              <a:t>16.08.2026</a:t>
             </a:fld>
             <a:endParaRPr lang="de-DE"/>
           </a:p>
@@ -1815,7 +1815,7 @@
           <a:p>
             <a:fld id="{0437B173-2941-45F4-97BE-951FF945D21E}" type="datetimeFigureOut">
               <a:rPr lang="de-DE" smtClean="0"/>
-              <a:t>04.08.2026</a:t>
+              <a:t>16.08.2026</a:t>
             </a:fld>
             <a:endParaRPr lang="de-DE"/>
           </a:p>
@@ -1956,7 +1956,7 @@
           <a:p>
             <a:fld id="{0437B173-2941-45F4-97BE-951FF945D21E}" type="datetimeFigureOut">
               <a:rPr lang="de-DE" smtClean="0"/>
-              <a:t>04.08.2026</a:t>
+              <a:t>16.08.2026</a:t>
             </a:fld>
             <a:endParaRPr lang="de-DE"/>
           </a:p>
@@ -2069,7 +2069,7 @@
           <a:p>
             <a:fld id="{0437B173-2941-45F4-97BE-951FF945D21E}" type="datetimeFigureOut">
               <a:rPr lang="de-DE" smtClean="0"/>
-              <a:t>04.08.2026</a:t>
+              <a:t>16.08.2026</a:t>
             </a:fld>
             <a:endParaRPr lang="de-DE"/>
           </a:p>
@@ -2380,7 +2380,7 @@
           <a:p>
             <a:fld id="{0437B173-2941-45F4-97BE-951FF945D21E}" type="datetimeFigureOut">
               <a:rPr lang="de-DE" smtClean="0"/>
-              <a:t>04.08.2026</a:t>
+              <a:t>16.08.2026</a:t>
             </a:fld>
             <a:endParaRPr lang="de-DE"/>
           </a:p>
@@ -2668,7 +2668,7 @@
           <a:p>
             <a:fld id="{0437B173-2941-45F4-97BE-951FF945D21E}" type="datetimeFigureOut">
               <a:rPr lang="de-DE" smtClean="0"/>
-              <a:t>04.08.2026</a:t>
+              <a:t>16.08.2026</a:t>
             </a:fld>
             <a:endParaRPr lang="de-DE"/>
           </a:p>
@@ -2909,7 +2909,7 @@
           <a:p>
             <a:fld id="{0437B173-2941-45F4-97BE-951FF945D21E}" type="datetimeFigureOut">
               <a:rPr lang="de-DE" smtClean="0"/>
-              <a:t>04.08.2026</a:t>
+              <a:t>16.08.2026</a:t>
             </a:fld>
             <a:endParaRPr lang="de-DE"/>
           </a:p>
@@ -3340,7 +3340,7 @@
         </p:nvSpPr>
         <p:spPr>
           <a:xfrm>
-            <a:off x="1972235" y="4984376"/>
+            <a:off x="582702" y="4984376"/>
             <a:ext cx="5034639" cy="720000"/>
           </a:xfrm>
           <a:prstGeom prst="rect">
@@ -3398,7 +3398,7 @@
         </p:nvSpPr>
         <p:spPr>
           <a:xfrm>
-            <a:off x="4846874" y="4010699"/>
+            <a:off x="3457341" y="4010699"/>
             <a:ext cx="2160000" cy="720000"/>
           </a:xfrm>
           <a:prstGeom prst="rect">
@@ -3447,7 +3447,7 @@
         </p:nvSpPr>
         <p:spPr>
           <a:xfrm>
-            <a:off x="1966876" y="4010699"/>
+            <a:off x="577343" y="4010699"/>
             <a:ext cx="2160000" cy="720000"/>
           </a:xfrm>
           <a:prstGeom prst="rect">
@@ -3496,7 +3496,7 @@
         </p:nvSpPr>
         <p:spPr>
           <a:xfrm>
-            <a:off x="1966876" y="3037022"/>
+            <a:off x="577343" y="3037022"/>
             <a:ext cx="2160000" cy="720000"/>
           </a:xfrm>
           <a:prstGeom prst="rect">
@@ -3555,7 +3555,7 @@
         </p:nvSpPr>
         <p:spPr>
           <a:xfrm>
-            <a:off x="4852235" y="3037022"/>
+            <a:off x="3462702" y="3037022"/>
             <a:ext cx="2160000" cy="720000"/>
           </a:xfrm>
           <a:prstGeom prst="rect">
@@ -3614,7 +3614,7 @@
         </p:nvSpPr>
         <p:spPr>
           <a:xfrm>
-            <a:off x="1966876" y="2063345"/>
+            <a:off x="577343" y="2063345"/>
             <a:ext cx="2160000" cy="720000"/>
           </a:xfrm>
           <a:prstGeom prst="rect">
@@ -3689,7 +3689,7 @@
         </p:nvSpPr>
         <p:spPr>
           <a:xfrm>
-            <a:off x="1966876" y="1089668"/>
+            <a:off x="577343" y="1089668"/>
             <a:ext cx="5034640" cy="720000"/>
           </a:xfrm>
           <a:prstGeom prst="rect">

</xml_diff>